<commit_message>
Add the model-routing decision to the deck
MODEL-ROSTER.md is a decision, not just a doc: Claude picks the delegate
model at runtime with no human checkpoint, so the deck needed the finding
behind the roster rather than a pointer to it. New slide 11 leads with the
AI_APICallError reframe — a Vercel AI SDK bug in the tool-calling
translation layer, not a model failure — and the routing verdict that falls
out of it: prefer/avoid by syntactic adherence, not reasoning score.

It sits directly after "never trust the return value" because a model that
returns a plan instead of editing files is the same false-success class.
The decision run renumbers 1-of-4 through 4-of-4 to 5.

Co-Authored-By: Claude Opus 5 <noreply@anthropic.com>
</commit_message>
<xml_diff>
--- a/docs/agent-delegation-mcp.pptx
+++ b/docs/agent-delegation-mcp.pptx
@@ -17,9 +17,10 @@
     <p:sldId id="265" r:id="rId11"/>
     <p:sldId id="266" r:id="rId12"/>
     <p:sldId id="267" r:id="rId13"/>
+    <p:sldId id="268" r:id="rId14"/>
   </p:sldIdLst>
   <p:notesMasterIdLst>
-    <p:notesMasterId r:id="rId14"/>
+    <p:notesMasterId r:id="rId15"/>
   </p:notesMasterIdLst>
   <p:sldSz cx="12192000" cy="6858000"/>
   <p:notesSz cx="6858000" cy="12192000"/>
@@ -978,7 +979,9 @@
           <a:p>
             <a:r>
               <a:rPr lang="en-US" dirty="0"/>
-              <a:t>This is the half that transfers even if you never delegate outside Anthropic. It is about supervising an agent you cannot watch.</a:t>
+              <a:t>Why this is a decision and not just a doc: Claude picks the delegate model at runtime with no human checkpoint, so a bad routing call is both expensive and invisible — the worst case is a model that returns a plan instead of editing files, which looks like success and leaves nothing on disk.
+The empty cells in the roster are the point. A guessed context window causes silent truncation rather than a visible error, so nothing is inferred from a sibling model or from the id itself; `unknown` means a thorough search found nothing. Locally-run probes stay in their own section — first-hand evidence about this harness outranks any leaderboard.
+Also worth saying out loud: block every muse-spark-*-contributor variant, free and paid, for proprietary code — Meta retains prompts and completions for training. And both deepseek tiers need an explicit workspace opt-in, so deepseek-v4-pro is the preferred target but not yet a usable default.</a:t>
             </a:r>
             <a:endParaRPr lang="en-US" dirty="0"/>
           </a:p>
@@ -1066,7 +1069,7 @@
           <a:p>
             <a:r>
               <a:rPr lang="en-US" dirty="0"/>
-              <a:t>Demo beat: dispatch a small real task, then Read the progress file mid-run to show there is visibility into a blocking subprocess. Close on the repo link.</a:t>
+              <a:t>This is the half that transfers even if you never delegate outside Anthropic. It is about supervising an agent you cannot watch.</a:t>
             </a:r>
             <a:endParaRPr lang="en-US" dirty="0"/>
           </a:p>
@@ -1090,6 +1093,94 @@
             <a:fld id="{F7021451-1387-4CA6-816F-3879F97B5CBC}" type="slidenum">
               <a:rPr lang="en-US"/>
               <a:t>12</a:t>
+            </a:fld>
+            <a:endParaRPr lang="en-US"/>
+          </a:p>
+        </p:txBody>
+      </p:sp>
+    </p:spTree>
+    <p:extLst>
+      <p:ext uri="{BB962C8B-B14F-4D97-AF65-F5344CB8AC3E}">
+        <p14:creationId xmlns:p14="http://schemas.microsoft.com/office/powerpoint/2010/main" val="1024086991"/>
+      </p:ext>
+    </p:extLst>
+  </p:cSld>
+  <p:clrMapOvr>
+    <a:masterClrMapping/>
+  </p:clrMapOvr>
+</p:notes>
+</file>
+
+<file path=ppt/notesSlides/notesSlide13.xml><?xml version="1.0" encoding="utf-8"?>
+<p:notes xmlns:a="http://schemas.openxmlformats.org/drawingml/2006/main" xmlns:r="http://schemas.openxmlformats.org/officeDocument/2006/relationships" xmlns:p="http://schemas.openxmlformats.org/presentationml/2006/main">
+  <p:cSld>
+    <p:spTree>
+      <p:nvGrpSpPr>
+        <p:cNvPr id="1" name=""/>
+        <p:cNvGrpSpPr/>
+        <p:nvPr/>
+      </p:nvGrpSpPr>
+      <p:grpSpPr>
+        <a:xfrm>
+          <a:off x="0" y="0"/>
+          <a:ext cx="0" cy="0"/>
+          <a:chOff x="0" y="0"/>
+          <a:chExt cx="0" cy="0"/>
+        </a:xfrm>
+      </p:grpSpPr>
+      <p:sp>
+        <p:nvSpPr>
+          <p:cNvPr id="2" name="Slide Image Placeholder 1"/>
+          <p:cNvSpPr>
+            <a:spLocks noGrp="1" noRot="1" noChangeAspect="1"/>
+          </p:cNvSpPr>
+          <p:nvPr>
+            <p:ph type="sldImg"/>
+          </p:nvPr>
+        </p:nvSpPr>
+        <p:spPr/>
+      </p:sp>
+      <p:sp>
+        <p:nvSpPr>
+          <p:cNvPr id="3" name="Notes Placeholder 2"/>
+          <p:cNvSpPr>
+            <a:spLocks noGrp="1"/>
+          </p:cNvSpPr>
+          <p:nvPr>
+            <p:ph type="body" idx="1"/>
+          </p:nvPr>
+        </p:nvSpPr>
+        <p:spPr/>
+        <p:txBody>
+          <a:bodyPr/>
+          <a:lstStyle/>
+          <a:p>
+            <a:r>
+              <a:rPr lang="en-US" dirty="0"/>
+              <a:t>Demo beat: dispatch a small real task, then Read the progress file mid-run to show there is visibility into a blocking subprocess. Close on the repo link.</a:t>
+            </a:r>
+            <a:endParaRPr lang="en-US" dirty="0"/>
+          </a:p>
+        </p:txBody>
+      </p:sp>
+      <p:sp>
+        <p:nvSpPr>
+          <p:cNvPr id="4" name="Slide Number Placeholder 3"/>
+          <p:cNvSpPr>
+            <a:spLocks noGrp="1"/>
+          </p:cNvSpPr>
+          <p:nvPr>
+            <p:ph type="sldNum" sz="quarter" idx="10"/>
+          </p:nvPr>
+        </p:nvSpPr>
+        <p:spPr/>
+        <p:txBody>
+          <a:bodyPr/>
+          <a:lstStyle/>
+          <a:p>
+            <a:fld id="{F7021451-1387-4CA6-816F-3879F97B5CBC}" type="slidenum">
+              <a:rPr lang="en-US"/>
+              <a:t>13</a:t>
             </a:fld>
             <a:endParaRPr lang="en-US"/>
           </a:p>
@@ -2599,7 +2690,7 @@
                 <a:ea typeface="Courier New" pitchFamily="34" charset="-122"/>
                 <a:cs typeface="Courier New" pitchFamily="34" charset="-120"/>
               </a:rPr>
-              <a:t>DECISIONS MADE · 3 OF 4</a:t>
+              <a:t>DECISIONS MADE · 3 OF 5</a:t>
             </a:r>
             <a:endParaRPr lang="en-US" sz="1100" dirty="0"/>
           </a:p>
@@ -3263,7 +3354,7 @@
                 <a:ea typeface="Arial" pitchFamily="34" charset="-122"/>
                 <a:cs typeface="Arial" pitchFamily="34" charset="-120"/>
               </a:rPr>
-              <a:t>Decision: the rules that outlive the wiring</a:t>
+              <a:t>Decision: route on tool-calling, not reasoning</a:t>
             </a:r>
             <a:endParaRPr lang="en-US" sz="3800" dirty="0"/>
           </a:p>
@@ -3302,7 +3393,7 @@
                 <a:ea typeface="Courier New" pitchFamily="34" charset="-122"/>
                 <a:cs typeface="Courier New" pitchFamily="34" charset="-120"/>
               </a:rPr>
-              <a:t>DECISIONS MADE · 4 OF 4 — THESE APPLY TO ANY UNATTENDED AGENT</a:t>
+              <a:t>DECISIONS MADE · 4 OF 5 — MODEL-ROSTER.MD, 34 IDS GRADED BY SOURCE CONFIDENCE</a:t>
             </a:r>
             <a:endParaRPr lang="en-US" sz="1100" dirty="0"/>
           </a:p>
@@ -3316,12 +3407,107 @@
         </p:nvSpPr>
         <p:spPr>
           <a:xfrm>
-            <a:off x="640080" y="1737360"/>
-            <a:ext cx="5272888" cy="1874520"/>
+            <a:off x="640080" y="1645920"/>
+            <a:ext cx="10911535" cy="1234440"/>
           </a:xfrm>
           <a:prstGeom prst="roundRect">
             <a:avLst>
-              <a:gd name="adj" fmla="val 2927"/>
+              <a:gd name="adj" fmla="val 4444"/>
+            </a:avLst>
+          </a:prstGeom>
+          <a:solidFill>
+            <a:srgbClr val="16191D"/>
+          </a:solidFill>
+          <a:ln w="12700">
+            <a:solidFill>
+              <a:srgbClr val="16191D"/>
+            </a:solidFill>
+            <a:prstDash val="solid"/>
+          </a:ln>
+        </p:spPr>
+      </p:sp>
+      <p:sp>
+        <p:nvSpPr>
+          <p:cNvPr id="5" name="Text 3"/>
+          <p:cNvSpPr txBox="1"/>
+          <p:nvPr/>
+        </p:nvSpPr>
+        <p:spPr>
+          <a:xfrm>
+            <a:off x="960120" y="1645920"/>
+            <a:ext cx="10271455" cy="1234440"/>
+          </a:xfrm>
+          <a:prstGeom prst="rect">
+            <a:avLst/>
+          </a:prstGeom>
+          <a:noFill/>
+          <a:ln/>
+        </p:spPr>
+        <p:txBody>
+          <a:bodyPr wrap="square" lIns="0" tIns="0" rIns="0" bIns="0" rtlCol="0" anchor="ctr"/>
+          <a:lstStyle/>
+          <a:p>
+            <a:pPr indent="0" marL="0">
+              <a:lnSpc>
+                <a:spcPct val="120000"/>
+              </a:lnSpc>
+              <a:spcBef>
+                <a:spcPts val="400"/>
+              </a:spcBef>
+              <a:buNone/>
+            </a:pPr>
+            <a:r>
+              <a:rPr lang="en-US" sz="1600" b="1" dirty="0">
+                <a:solidFill>
+                  <a:srgbClr val="F0C48A"/>
+                </a:solidFill>
+                <a:latin typeface="Arial" pitchFamily="34" charset="0"/>
+                <a:ea typeface="Arial" pitchFamily="34" charset="-122"/>
+                <a:cs typeface="Arial" pitchFamily="34" charset="-120"/>
+              </a:rPr>
+              <a:t>AI_APICallError is a Vercel AI SDK bug, not a model bug.</a:t>
+            </a:r>
+            <a:endParaRPr lang="en-US" sz="1600" dirty="0"/>
+          </a:p>
+          <a:p>
+            <a:pPr indent="0" marL="0">
+              <a:lnSpc>
+                <a:spcPct val="120000"/>
+              </a:lnSpc>
+              <a:spcBef>
+                <a:spcPts val="400"/>
+              </a:spcBef>
+              <a:buNone/>
+            </a:pPr>
+            <a:r>
+              <a:rPr lang="en-US" sz="1350" dirty="0">
+                <a:solidFill>
+                  <a:srgbClr val="D5D9DE"/>
+                </a:solidFill>
+                <a:latin typeface="Calibri" pitchFamily="34" charset="0"/>
+                <a:ea typeface="Calibri" pitchFamily="34" charset="-122"/>
+                <a:cs typeface="Calibri" pitchFamily="34" charset="-120"/>
+              </a:rPr>
+              <a:t>On follow-up turns the SDK strips the assistant's function_call item when it carries a provider item ID — then still sends the matching function_call_output. The orphaned output is a fatal 400. The translation layer under OpenCode breaks the loop, not the model.</a:t>
+            </a:r>
+            <a:endParaRPr lang="en-US" sz="1600" dirty="0"/>
+          </a:p>
+        </p:txBody>
+      </p:sp>
+      <p:sp>
+        <p:nvSpPr>
+          <p:cNvPr id="6" name="Shape 4"/>
+          <p:cNvSpPr/>
+          <p:nvPr/>
+        </p:nvSpPr>
+        <p:spPr>
+          <a:xfrm>
+            <a:off x="640080" y="3108960"/>
+            <a:ext cx="5272888" cy="2103120"/>
+          </a:xfrm>
+          <a:prstGeom prst="roundRect">
+            <a:avLst>
+              <a:gd name="adj" fmla="val 2609"/>
             </a:avLst>
           </a:prstGeom>
           <a:solidFill>
@@ -3337,134 +3523,83 @@
       </p:sp>
       <p:sp>
         <p:nvSpPr>
-          <p:cNvPr id="5" name="Shape 3"/>
-          <p:cNvSpPr/>
-          <p:nvPr/>
-        </p:nvSpPr>
-        <p:spPr>
-          <a:xfrm>
-            <a:off x="914400" y="1993392"/>
-            <a:ext cx="384048" cy="384048"/>
-          </a:xfrm>
-          <a:prstGeom prst="ellipse">
-            <a:avLst/>
-          </a:prstGeom>
-          <a:solidFill>
-            <a:srgbClr val="6D4AC4"/>
-          </a:solidFill>
-          <a:ln/>
-        </p:spPr>
-      </p:sp>
-      <p:sp>
-        <p:nvSpPr>
-          <p:cNvPr id="6" name="Text 4"/>
-          <p:cNvSpPr txBox="1"/>
-          <p:nvPr/>
-        </p:nvSpPr>
-        <p:spPr>
-          <a:xfrm>
-            <a:off x="914400" y="1993392"/>
-            <a:ext cx="384048" cy="384048"/>
-          </a:xfrm>
-          <a:prstGeom prst="rect">
-            <a:avLst/>
-          </a:prstGeom>
-          <a:noFill/>
-          <a:ln/>
-        </p:spPr>
-        <p:txBody>
-          <a:bodyPr wrap="square" lIns="0" tIns="0" rIns="0" bIns="0" rtlCol="0" anchor="ctr"/>
-          <a:lstStyle/>
-          <a:p>
-            <a:pPr algn="ctr" indent="0" marL="0">
-              <a:buNone/>
-            </a:pPr>
-            <a:r>
-              <a:rPr lang="en-US" sz="1300" b="1" dirty="0">
-                <a:solidFill>
-                  <a:srgbClr val="FFFFFF"/>
+          <p:cNvPr id="7" name="Text 5"/>
+          <p:cNvSpPr txBox="1"/>
+          <p:nvPr/>
+        </p:nvSpPr>
+        <p:spPr>
+          <a:xfrm>
+            <a:off x="896112" y="3255264"/>
+            <a:ext cx="4760824" cy="274320"/>
+          </a:xfrm>
+          <a:prstGeom prst="rect">
+            <a:avLst/>
+          </a:prstGeom>
+          <a:noFill/>
+          <a:ln/>
+        </p:spPr>
+        <p:txBody>
+          <a:bodyPr wrap="square" lIns="0" tIns="0" rIns="0" bIns="0" rtlCol="0" anchor="ctr"/>
+          <a:lstStyle/>
+          <a:p>
+            <a:pPr indent="0" marL="0">
+              <a:buNone/>
+            </a:pPr>
+            <a:r>
+              <a:rPr lang="en-US" sz="1600" b="1" dirty="0">
+                <a:solidFill>
+                  <a:srgbClr val="17795E"/>
+                </a:solidFill>
+                <a:latin typeface="Arial" pitchFamily="34" charset="0"/>
+                <a:ea typeface="Arial" pitchFamily="34" charset="-122"/>
+                <a:cs typeface="Arial" pitchFamily="34" charset="-120"/>
+              </a:rPr>
+              <a:t>Prefer</a:t>
+            </a:r>
+            <a:endParaRPr lang="en-US" sz="1600" dirty="0"/>
+          </a:p>
+        </p:txBody>
+      </p:sp>
+      <p:sp>
+        <p:nvSpPr>
+          <p:cNvPr id="8" name="Text 6"/>
+          <p:cNvSpPr txBox="1"/>
+          <p:nvPr/>
+        </p:nvSpPr>
+        <p:spPr>
+          <a:xfrm>
+            <a:off x="896112" y="3611880"/>
+            <a:ext cx="4760824" cy="365760"/>
+          </a:xfrm>
+          <a:prstGeom prst="rect">
+            <a:avLst/>
+          </a:prstGeom>
+          <a:noFill/>
+          <a:ln/>
+        </p:spPr>
+        <p:txBody>
+          <a:bodyPr wrap="square" lIns="0" tIns="0" rIns="0" bIns="0" rtlCol="0" anchor="ctr"/>
+          <a:lstStyle/>
+          <a:p>
+            <a:pPr indent="0" marL="0">
+              <a:buNone/>
+            </a:pPr>
+            <a:r>
+              <a:rPr lang="en-US" sz="1150" b="1" dirty="0">
+                <a:solidFill>
+                  <a:srgbClr val="17795E"/>
                 </a:solidFill>
                 <a:latin typeface="Courier New" pitchFamily="34" charset="0"/>
                 <a:ea typeface="Courier New" pitchFamily="34" charset="-122"/>
                 <a:cs typeface="Courier New" pitchFamily="34" charset="-120"/>
               </a:rPr>
-              <a:t>1</a:t>
-            </a:r>
-            <a:endParaRPr lang="en-US" sz="1300" dirty="0"/>
-          </a:p>
-        </p:txBody>
-      </p:sp>
-      <p:sp>
-        <p:nvSpPr>
-          <p:cNvPr id="7" name="Text 5"/>
-          <p:cNvSpPr txBox="1"/>
-          <p:nvPr/>
-        </p:nvSpPr>
-        <p:spPr>
-          <a:xfrm>
-            <a:off x="1481328" y="1956816"/>
-            <a:ext cx="4175608" cy="475488"/>
-          </a:xfrm>
-          <a:prstGeom prst="rect">
-            <a:avLst/>
-          </a:prstGeom>
-          <a:noFill/>
-          <a:ln/>
-        </p:spPr>
-        <p:txBody>
-          <a:bodyPr wrap="square" lIns="0" tIns="0" rIns="0" bIns="0" rtlCol="0" anchor="ctr"/>
-          <a:lstStyle/>
-          <a:p>
-            <a:pPr indent="0" marL="0">
-              <a:lnSpc>
-                <a:spcPct val="110000"/>
-              </a:lnSpc>
-              <a:buNone/>
-            </a:pPr>
-            <a:r>
-              <a:rPr lang="en-US" sz="1600" b="1" dirty="0">
-                <a:solidFill>
-                  <a:srgbClr val="16191D"/>
-                </a:solidFill>
-                <a:latin typeface="Arial" pitchFamily="34" charset="0"/>
-                <a:ea typeface="Arial" pitchFamily="34" charset="-122"/>
-                <a:cs typeface="Arial" pitchFamily="34" charset="-120"/>
-              </a:rPr>
-              <a:t>The deliverable is a file, never stdout</a:t>
-            </a:r>
-            <a:endParaRPr lang="en-US" sz="1600" dirty="0"/>
-          </a:p>
-        </p:txBody>
-      </p:sp>
-      <p:sp>
-        <p:nvSpPr>
-          <p:cNvPr id="8" name="Text 6"/>
-          <p:cNvSpPr txBox="1"/>
-          <p:nvPr/>
-        </p:nvSpPr>
-        <p:spPr>
-          <a:xfrm>
-            <a:off x="914400" y="2542032"/>
-            <a:ext cx="4724248" cy="914400"/>
-          </a:xfrm>
-          <a:prstGeom prst="rect">
-            <a:avLst/>
-          </a:prstGeom>
-          <a:noFill/>
-          <a:ln/>
-        </p:spPr>
-        <p:txBody>
-          <a:bodyPr wrap="square" lIns="0" tIns="0" rIns="0" bIns="0" rtlCol="0" anchor="t"/>
-          <a:lstStyle/>
-          <a:p>
-            <a:pPr indent="0" marL="0">
-              <a:lnSpc>
-                <a:spcPct val="118000"/>
-              </a:lnSpc>
-              <a:buNone/>
-            </a:pPr>
-            <a:r>
-              <a:rPr lang="en-US" sz="1300" dirty="0">
+              <a:t>deepseek-v4-pro</a:t>
+            </a:r>
+            <a:pPr indent="0" marL="0">
+              <a:buNone/>
+            </a:pPr>
+            <a:r>
+              <a:rPr lang="en-US" sz="1250" dirty="0">
                 <a:solidFill>
                   <a:srgbClr val="16191D"/>
                 </a:solidFill>
@@ -3472,26 +3607,132 @@
                 <a:ea typeface="Calibri" pitchFamily="34" charset="-122"/>
                 <a:cs typeface="Calibri" pitchFamily="34" charset="-120"/>
               </a:rPr>
-              <a:t>stdout is lost outright when the transport drops and truncated when a run is killed. A brief that says "print your review" has a total-loss failure mode — verified on an hour of real work.</a:t>
-            </a:r>
-            <a:endParaRPr lang="en-US" sz="1300" dirty="0"/>
-          </a:p>
-        </p:txBody>
-      </p:sp>
-      <p:sp>
-        <p:nvSpPr>
-          <p:cNvPr id="9" name="Shape 7"/>
+              <a:t> — keeps reasoning state across tool calls</a:t>
+            </a:r>
+            <a:endParaRPr lang="en-US" sz="1150" dirty="0"/>
+          </a:p>
+        </p:txBody>
+      </p:sp>
+      <p:sp>
+        <p:nvSpPr>
+          <p:cNvPr id="9" name="Text 7"/>
+          <p:cNvSpPr txBox="1"/>
+          <p:nvPr/>
+        </p:nvSpPr>
+        <p:spPr>
+          <a:xfrm>
+            <a:off x="896112" y="3995928"/>
+            <a:ext cx="4760824" cy="365760"/>
+          </a:xfrm>
+          <a:prstGeom prst="rect">
+            <a:avLst/>
+          </a:prstGeom>
+          <a:noFill/>
+          <a:ln/>
+        </p:spPr>
+        <p:txBody>
+          <a:bodyPr wrap="square" lIns="0" tIns="0" rIns="0" bIns="0" rtlCol="0" anchor="ctr"/>
+          <a:lstStyle/>
+          <a:p>
+            <a:pPr indent="0" marL="0">
+              <a:buNone/>
+            </a:pPr>
+            <a:r>
+              <a:rPr lang="en-US" sz="1150" b="1" dirty="0">
+                <a:solidFill>
+                  <a:srgbClr val="17795E"/>
+                </a:solidFill>
+                <a:latin typeface="Courier New" pitchFamily="34" charset="0"/>
+                <a:ea typeface="Courier New" pitchFamily="34" charset="-122"/>
+                <a:cs typeface="Courier New" pitchFamily="34" charset="-120"/>
+              </a:rPr>
+              <a:t>minimax-m3</a:t>
+            </a:r>
+            <a:pPr indent="0" marL="0">
+              <a:buNone/>
+            </a:pPr>
+            <a:r>
+              <a:rPr lang="en-US" sz="1250" dirty="0">
+                <a:solidFill>
+                  <a:srgbClr val="16191D"/>
+                </a:solidFill>
+                <a:latin typeface="Calibri" pitchFamily="34" charset="0"/>
+                <a:ea typeface="Calibri" pitchFamily="34" charset="-122"/>
+                <a:cs typeface="Calibri" pitchFamily="34" charset="-120"/>
+              </a:rPr>
+              <a:t> — ~24h / 1,959 tool calls unattended, at 100 tok/s</a:t>
+            </a:r>
+            <a:endParaRPr lang="en-US" sz="1150" dirty="0"/>
+          </a:p>
+        </p:txBody>
+      </p:sp>
+      <p:sp>
+        <p:nvSpPr>
+          <p:cNvPr id="10" name="Text 8"/>
+          <p:cNvSpPr txBox="1"/>
+          <p:nvPr/>
+        </p:nvSpPr>
+        <p:spPr>
+          <a:xfrm>
+            <a:off x="896112" y="4379976"/>
+            <a:ext cx="4760824" cy="365760"/>
+          </a:xfrm>
+          <a:prstGeom prst="rect">
+            <a:avLst/>
+          </a:prstGeom>
+          <a:noFill/>
+          <a:ln/>
+        </p:spPr>
+        <p:txBody>
+          <a:bodyPr wrap="square" lIns="0" tIns="0" rIns="0" bIns="0" rtlCol="0" anchor="ctr"/>
+          <a:lstStyle/>
+          <a:p>
+            <a:pPr indent="0" marL="0">
+              <a:buNone/>
+            </a:pPr>
+            <a:r>
+              <a:rPr lang="en-US" sz="1150" b="1" dirty="0">
+                <a:solidFill>
+                  <a:srgbClr val="17795E"/>
+                </a:solidFill>
+                <a:latin typeface="Courier New" pitchFamily="34" charset="0"/>
+                <a:ea typeface="Courier New" pitchFamily="34" charset="-122"/>
+                <a:cs typeface="Courier New" pitchFamily="34" charset="-120"/>
+              </a:rPr>
+              <a:t>qwen3.8-flash</a:t>
+            </a:r>
+            <a:pPr indent="0" marL="0">
+              <a:buNone/>
+            </a:pPr>
+            <a:r>
+              <a:rPr lang="en-US" sz="1250" dirty="0">
+                <a:solidFill>
+                  <a:srgbClr val="16191D"/>
+                </a:solidFill>
+                <a:latin typeface="Calibri" pitchFamily="34" charset="0"/>
+                <a:ea typeface="Calibri" pitchFamily="34" charset="-122"/>
+                <a:cs typeface="Calibri" pitchFamily="34" charset="-120"/>
+              </a:rPr>
+              <a:t> — the cheap pick for high-volume iteration</a:t>
+            </a:r>
+            <a:endParaRPr lang="en-US" sz="1150" dirty="0"/>
+          </a:p>
+        </p:txBody>
+      </p:sp>
+      <p:sp>
+        <p:nvSpPr>
+          <p:cNvPr id="11" name="Shape 9"/>
           <p:cNvSpPr/>
           <p:nvPr/>
         </p:nvSpPr>
         <p:spPr>
           <a:xfrm>
-            <a:off x="6278728" y="1737360"/>
-            <a:ext cx="5272888" cy="1874520"/>
+            <a:off x="6278728" y="3108960"/>
+            <a:ext cx="5272888" cy="2103120"/>
           </a:xfrm>
           <a:prstGeom prst="roundRect">
             <a:avLst>
-              <a:gd name="adj" fmla="val 2927"/>
+              <a:gd name="adj" fmla="val 2609"/>
             </a:avLst>
           </a:prstGeom>
           <a:solidFill>
@@ -3507,134 +3748,83 @@
       </p:sp>
       <p:sp>
         <p:nvSpPr>
-          <p:cNvPr id="10" name="Shape 8"/>
-          <p:cNvSpPr/>
-          <p:nvPr/>
-        </p:nvSpPr>
-        <p:spPr>
-          <a:xfrm>
-            <a:off x="6553048" y="1993392"/>
-            <a:ext cx="384048" cy="384048"/>
-          </a:xfrm>
-          <a:prstGeom prst="ellipse">
-            <a:avLst/>
-          </a:prstGeom>
-          <a:solidFill>
-            <a:srgbClr val="17795E"/>
-          </a:solidFill>
-          <a:ln/>
-        </p:spPr>
-      </p:sp>
-      <p:sp>
-        <p:nvSpPr>
-          <p:cNvPr id="11" name="Text 9"/>
-          <p:cNvSpPr txBox="1"/>
-          <p:nvPr/>
-        </p:nvSpPr>
-        <p:spPr>
-          <a:xfrm>
-            <a:off x="6553048" y="1993392"/>
-            <a:ext cx="384048" cy="384048"/>
-          </a:xfrm>
-          <a:prstGeom prst="rect">
-            <a:avLst/>
-          </a:prstGeom>
-          <a:noFill/>
-          <a:ln/>
-        </p:spPr>
-        <p:txBody>
-          <a:bodyPr wrap="square" lIns="0" tIns="0" rIns="0" bIns="0" rtlCol="0" anchor="ctr"/>
-          <a:lstStyle/>
-          <a:p>
-            <a:pPr algn="ctr" indent="0" marL="0">
-              <a:buNone/>
-            </a:pPr>
-            <a:r>
-              <a:rPr lang="en-US" sz="1300" b="1" dirty="0">
-                <a:solidFill>
-                  <a:srgbClr val="FFFFFF"/>
+          <p:cNvPr id="12" name="Text 10"/>
+          <p:cNvSpPr txBox="1"/>
+          <p:nvPr/>
+        </p:nvSpPr>
+        <p:spPr>
+          <a:xfrm>
+            <a:off x="6534760" y="3255264"/>
+            <a:ext cx="4760824" cy="274320"/>
+          </a:xfrm>
+          <a:prstGeom prst="rect">
+            <a:avLst/>
+          </a:prstGeom>
+          <a:noFill/>
+          <a:ln/>
+        </p:spPr>
+        <p:txBody>
+          <a:bodyPr wrap="square" lIns="0" tIns="0" rIns="0" bIns="0" rtlCol="0" anchor="ctr"/>
+          <a:lstStyle/>
+          <a:p>
+            <a:pPr indent="0" marL="0">
+              <a:buNone/>
+            </a:pPr>
+            <a:r>
+              <a:rPr lang="en-US" sz="1600" b="1" dirty="0">
+                <a:solidFill>
+                  <a:srgbClr val="C1690C"/>
+                </a:solidFill>
+                <a:latin typeface="Arial" pitchFamily="34" charset="0"/>
+                <a:ea typeface="Arial" pitchFamily="34" charset="-122"/>
+                <a:cs typeface="Arial" pitchFamily="34" charset="-120"/>
+              </a:rPr>
+              <a:t>Strictly avoid</a:t>
+            </a:r>
+            <a:endParaRPr lang="en-US" sz="1600" dirty="0"/>
+          </a:p>
+        </p:txBody>
+      </p:sp>
+      <p:sp>
+        <p:nvSpPr>
+          <p:cNvPr id="13" name="Text 11"/>
+          <p:cNvSpPr txBox="1"/>
+          <p:nvPr/>
+        </p:nvSpPr>
+        <p:spPr>
+          <a:xfrm>
+            <a:off x="6534760" y="3611880"/>
+            <a:ext cx="4760824" cy="365760"/>
+          </a:xfrm>
+          <a:prstGeom prst="rect">
+            <a:avLst/>
+          </a:prstGeom>
+          <a:noFill/>
+          <a:ln/>
+        </p:spPr>
+        <p:txBody>
+          <a:bodyPr wrap="square" lIns="0" tIns="0" rIns="0" bIns="0" rtlCol="0" anchor="ctr"/>
+          <a:lstStyle/>
+          <a:p>
+            <a:pPr indent="0" marL="0">
+              <a:buNone/>
+            </a:pPr>
+            <a:r>
+              <a:rPr lang="en-US" sz="1150" b="1" dirty="0">
+                <a:solidFill>
+                  <a:srgbClr val="C1690C"/>
                 </a:solidFill>
                 <a:latin typeface="Courier New" pitchFamily="34" charset="0"/>
                 <a:ea typeface="Courier New" pitchFamily="34" charset="-122"/>
                 <a:cs typeface="Courier New" pitchFamily="34" charset="-120"/>
               </a:rPr>
-              <a:t>2</a:t>
-            </a:r>
-            <a:endParaRPr lang="en-US" sz="1300" dirty="0"/>
-          </a:p>
-        </p:txBody>
-      </p:sp>
-      <p:sp>
-        <p:nvSpPr>
-          <p:cNvPr id="12" name="Text 10"/>
-          <p:cNvSpPr txBox="1"/>
-          <p:nvPr/>
-        </p:nvSpPr>
-        <p:spPr>
-          <a:xfrm>
-            <a:off x="7119976" y="1956816"/>
-            <a:ext cx="4175608" cy="475488"/>
-          </a:xfrm>
-          <a:prstGeom prst="rect">
-            <a:avLst/>
-          </a:prstGeom>
-          <a:noFill/>
-          <a:ln/>
-        </p:spPr>
-        <p:txBody>
-          <a:bodyPr wrap="square" lIns="0" tIns="0" rIns="0" bIns="0" rtlCol="0" anchor="ctr"/>
-          <a:lstStyle/>
-          <a:p>
-            <a:pPr indent="0" marL="0">
-              <a:lnSpc>
-                <a:spcPct val="110000"/>
-              </a:lnSpc>
-              <a:buNone/>
-            </a:pPr>
-            <a:r>
-              <a:rPr lang="en-US" sz="1600" b="1" dirty="0">
-                <a:solidFill>
-                  <a:srgbClr val="16191D"/>
-                </a:solidFill>
-                <a:latin typeface="Arial" pitchFamily="34" charset="0"/>
-                <a:ea typeface="Arial" pitchFamily="34" charset="-122"/>
-                <a:cs typeface="Arial" pitchFamily="34" charset="-120"/>
-              </a:rPr>
-              <a:t>Match plan detail to model strength</a:t>
-            </a:r>
-            <a:endParaRPr lang="en-US" sz="1600" dirty="0"/>
-          </a:p>
-        </p:txBody>
-      </p:sp>
-      <p:sp>
-        <p:nvSpPr>
-          <p:cNvPr id="13" name="Text 11"/>
-          <p:cNvSpPr txBox="1"/>
-          <p:nvPr/>
-        </p:nvSpPr>
-        <p:spPr>
-          <a:xfrm>
-            <a:off x="6553048" y="2542032"/>
-            <a:ext cx="4724248" cy="914400"/>
-          </a:xfrm>
-          <a:prstGeom prst="rect">
-            <a:avLst/>
-          </a:prstGeom>
-          <a:noFill/>
-          <a:ln/>
-        </p:spPr>
-        <p:txBody>
-          <a:bodyPr wrap="square" lIns="0" tIns="0" rIns="0" bIns="0" rtlCol="0" anchor="t"/>
-          <a:lstStyle/>
-          <a:p>
-            <a:pPr indent="0" marL="0">
-              <a:lnSpc>
-                <a:spcPct val="118000"/>
-              </a:lnSpc>
-              <a:buNone/>
-            </a:pPr>
-            <a:r>
-              <a:rPr lang="en-US" sz="1300" dirty="0">
+              <a:t>kimi-k2.6</a:t>
+            </a:r>
+            <a:pPr indent="0" marL="0">
+              <a:buNone/>
+            </a:pPr>
+            <a:r>
+              <a:rPr lang="en-US" sz="1250" dirty="0">
                 <a:solidFill>
                   <a:srgbClr val="16191D"/>
                 </a:solidFill>
@@ -3642,34 +3832,193 @@
                 <a:ea typeface="Calibri" pitchFamily="34" charset="-122"/>
                 <a:cs typeface="Calibri" pitchFamily="34" charset="-120"/>
               </a:rPr>
-              <a:t>Flash tier gets exact files, exact before/after code, an explicit do-not-touch list, and zero open questions. Frontier tier gets intent, invariants and phase gates.</a:t>
-            </a:r>
-            <a:endParaRPr lang="en-US" sz="1300" dirty="0"/>
-          </a:p>
-        </p:txBody>
-      </p:sp>
-      <p:sp>
-        <p:nvSpPr>
-          <p:cNvPr id="14" name="Shape 12"/>
+              <a:t> — infinite repetition exhausts the context</a:t>
+            </a:r>
+            <a:endParaRPr lang="en-US" sz="1150" dirty="0"/>
+          </a:p>
+        </p:txBody>
+      </p:sp>
+      <p:sp>
+        <p:nvSpPr>
+          <p:cNvPr id="14" name="Text 12"/>
+          <p:cNvSpPr txBox="1"/>
+          <p:nvPr/>
+        </p:nvSpPr>
+        <p:spPr>
+          <a:xfrm>
+            <a:off x="6534760" y="3995928"/>
+            <a:ext cx="4760824" cy="365760"/>
+          </a:xfrm>
+          <a:prstGeom prst="rect">
+            <a:avLst/>
+          </a:prstGeom>
+          <a:noFill/>
+          <a:ln/>
+        </p:spPr>
+        <p:txBody>
+          <a:bodyPr wrap="square" lIns="0" tIns="0" rIns="0" bIns="0" rtlCol="0" anchor="ctr"/>
+          <a:lstStyle/>
+          <a:p>
+            <a:pPr indent="0" marL="0">
+              <a:buNone/>
+            </a:pPr>
+            <a:r>
+              <a:rPr lang="en-US" sz="1150" b="1" dirty="0">
+                <a:solidFill>
+                  <a:srgbClr val="C1690C"/>
+                </a:solidFill>
+                <a:latin typeface="Courier New" pitchFamily="34" charset="0"/>
+                <a:ea typeface="Courier New" pitchFamily="34" charset="-122"/>
+                <a:cs typeface="Courier New" pitchFamily="34" charset="-120"/>
+              </a:rPr>
+              <a:t>glm-5.3-flash</a:t>
+            </a:r>
+            <a:pPr indent="0" marL="0">
+              <a:buNone/>
+            </a:pPr>
+            <a:r>
+              <a:rPr lang="en-US" sz="1250" dirty="0">
+                <a:solidFill>
+                  <a:srgbClr val="16191D"/>
+                </a:solidFill>
+                <a:latin typeface="Calibri" pitchFamily="34" charset="0"/>
+                <a:ea typeface="Calibri" pitchFamily="34" charset="-122"/>
+                <a:cs typeface="Calibri" pitchFamily="34" charset="-120"/>
+              </a:rPr>
+              <a:t> — 40–186s per call breaches the wall clock</a:t>
+            </a:r>
+            <a:endParaRPr lang="en-US" sz="1150" dirty="0"/>
+          </a:p>
+        </p:txBody>
+      </p:sp>
+      <p:sp>
+        <p:nvSpPr>
+          <p:cNvPr id="15" name="Text 13"/>
+          <p:cNvSpPr txBox="1"/>
+          <p:nvPr/>
+        </p:nvSpPr>
+        <p:spPr>
+          <a:xfrm>
+            <a:off x="6534760" y="4379976"/>
+            <a:ext cx="4760824" cy="365760"/>
+          </a:xfrm>
+          <a:prstGeom prst="rect">
+            <a:avLst/>
+          </a:prstGeom>
+          <a:noFill/>
+          <a:ln/>
+        </p:spPr>
+        <p:txBody>
+          <a:bodyPr wrap="square" lIns="0" tIns="0" rIns="0" bIns="0" rtlCol="0" anchor="ctr"/>
+          <a:lstStyle/>
+          <a:p>
+            <a:pPr indent="0" marL="0">
+              <a:buNone/>
+            </a:pPr>
+            <a:r>
+              <a:rPr lang="en-US" sz="1150" b="1" dirty="0">
+                <a:solidFill>
+                  <a:srgbClr val="C1690C"/>
+                </a:solidFill>
+                <a:latin typeface="Courier New" pitchFamily="34" charset="0"/>
+                <a:ea typeface="Courier New" pitchFamily="34" charset="-122"/>
+                <a:cs typeface="Courier New" pitchFamily="34" charset="-120"/>
+              </a:rPr>
+              <a:t>nemotron-3.5-lightning-free</a:t>
+            </a:r>
+            <a:pPr indent="0" marL="0">
+              <a:buNone/>
+            </a:pPr>
+            <a:r>
+              <a:rPr lang="en-US" sz="1250" dirty="0">
+                <a:solidFill>
+                  <a:srgbClr val="16191D"/>
+                </a:solidFill>
+                <a:latin typeface="Calibri" pitchFamily="34" charset="0"/>
+                <a:ea typeface="Calibri" pitchFamily="34" charset="-122"/>
+                <a:cs typeface="Calibri" pitchFamily="34" charset="-120"/>
+              </a:rPr>
+              <a:t> — drops tool-JSON closing braces</a:t>
+            </a:r>
+            <a:endParaRPr lang="en-US" sz="1150" dirty="0"/>
+          </a:p>
+        </p:txBody>
+      </p:sp>
+      <p:sp>
+        <p:nvSpPr>
+          <p:cNvPr id="16" name="Text 14"/>
+          <p:cNvSpPr txBox="1"/>
+          <p:nvPr/>
+        </p:nvSpPr>
+        <p:spPr>
+          <a:xfrm>
+            <a:off x="6534760" y="4764024"/>
+            <a:ext cx="4760824" cy="365760"/>
+          </a:xfrm>
+          <a:prstGeom prst="rect">
+            <a:avLst/>
+          </a:prstGeom>
+          <a:noFill/>
+          <a:ln/>
+        </p:spPr>
+        <p:txBody>
+          <a:bodyPr wrap="square" lIns="0" tIns="0" rIns="0" bIns="0" rtlCol="0" anchor="ctr"/>
+          <a:lstStyle/>
+          <a:p>
+            <a:pPr indent="0" marL="0">
+              <a:buNone/>
+            </a:pPr>
+            <a:r>
+              <a:rPr lang="en-US" sz="1150" b="1" dirty="0">
+                <a:solidFill>
+                  <a:srgbClr val="C1690C"/>
+                </a:solidFill>
+                <a:latin typeface="Courier New" pitchFamily="34" charset="0"/>
+                <a:ea typeface="Courier New" pitchFamily="34" charset="-122"/>
+                <a:cs typeface="Courier New" pitchFamily="34" charset="-120"/>
+              </a:rPr>
+              <a:t>omen-alpha</a:t>
+            </a:r>
+            <a:pPr indent="0" marL="0">
+              <a:buNone/>
+            </a:pPr>
+            <a:r>
+              <a:rPr lang="en-US" sz="1250" dirty="0">
+                <a:solidFill>
+                  <a:srgbClr val="16191D"/>
+                </a:solidFill>
+                <a:latin typeface="Calibri" pitchFamily="34" charset="0"/>
+                <a:ea typeface="Calibri" pitchFamily="34" charset="-122"/>
+                <a:cs typeface="Calibri" pitchFamily="34" charset="-120"/>
+              </a:rPr>
+              <a:t> — ignores the tools, rewrites files from scratch</a:t>
+            </a:r>
+            <a:endParaRPr lang="en-US" sz="1150" dirty="0"/>
+          </a:p>
+        </p:txBody>
+      </p:sp>
+      <p:sp>
+        <p:nvSpPr>
+          <p:cNvPr id="17" name="Shape 15"/>
           <p:cNvSpPr/>
           <p:nvPr/>
         </p:nvSpPr>
         <p:spPr>
           <a:xfrm>
-            <a:off x="640080" y="3840480"/>
-            <a:ext cx="5272888" cy="1874520"/>
+            <a:off x="640080" y="5394960"/>
+            <a:ext cx="10911535" cy="713232"/>
           </a:xfrm>
           <a:prstGeom prst="roundRect">
             <a:avLst>
-              <a:gd name="adj" fmla="val 2927"/>
+              <a:gd name="adj" fmla="val 7692"/>
             </a:avLst>
           </a:prstGeom>
           <a:solidFill>
-            <a:srgbClr val="F4F5F7"/>
+            <a:srgbClr val="FCF1DF"/>
           </a:solidFill>
           <a:ln w="12700">
             <a:solidFill>
-              <a:srgbClr val="DCE0E6"/>
+              <a:srgbClr val="EBCFA4"/>
             </a:solidFill>
             <a:prstDash val="solid"/>
           </a:ln>
@@ -3677,134 +4026,30 @@
       </p:sp>
       <p:sp>
         <p:nvSpPr>
-          <p:cNvPr id="15" name="Shape 13"/>
-          <p:cNvSpPr/>
-          <p:nvPr/>
-        </p:nvSpPr>
-        <p:spPr>
-          <a:xfrm>
-            <a:off x="914400" y="4096512"/>
-            <a:ext cx="384048" cy="384048"/>
-          </a:xfrm>
-          <a:prstGeom prst="ellipse">
-            <a:avLst/>
-          </a:prstGeom>
-          <a:solidFill>
-            <a:srgbClr val="6D4AC4"/>
-          </a:solidFill>
-          <a:ln/>
-        </p:spPr>
-      </p:sp>
-      <p:sp>
-        <p:nvSpPr>
-          <p:cNvPr id="16" name="Text 14"/>
-          <p:cNvSpPr txBox="1"/>
-          <p:nvPr/>
-        </p:nvSpPr>
-        <p:spPr>
-          <a:xfrm>
-            <a:off x="914400" y="4096512"/>
-            <a:ext cx="384048" cy="384048"/>
-          </a:xfrm>
-          <a:prstGeom prst="rect">
-            <a:avLst/>
-          </a:prstGeom>
-          <a:noFill/>
-          <a:ln/>
-        </p:spPr>
-        <p:txBody>
-          <a:bodyPr wrap="square" lIns="0" tIns="0" rIns="0" bIns="0" rtlCol="0" anchor="ctr"/>
-          <a:lstStyle/>
-          <a:p>
-            <a:pPr algn="ctr" indent="0" marL="0">
-              <a:buNone/>
-            </a:pPr>
-            <a:r>
-              <a:rPr lang="en-US" sz="1300" b="1" dirty="0">
-                <a:solidFill>
-                  <a:srgbClr val="FFFFFF"/>
-                </a:solidFill>
-                <a:latin typeface="Courier New" pitchFamily="34" charset="0"/>
-                <a:ea typeface="Courier New" pitchFamily="34" charset="-122"/>
-                <a:cs typeface="Courier New" pitchFamily="34" charset="-120"/>
-              </a:rPr>
-              <a:t>3</a:t>
-            </a:r>
-            <a:endParaRPr lang="en-US" sz="1300" dirty="0"/>
-          </a:p>
-        </p:txBody>
-      </p:sp>
-      <p:sp>
-        <p:nvSpPr>
-          <p:cNvPr id="17" name="Text 15"/>
-          <p:cNvSpPr txBox="1"/>
-          <p:nvPr/>
-        </p:nvSpPr>
-        <p:spPr>
-          <a:xfrm>
-            <a:off x="1481328" y="4059936"/>
-            <a:ext cx="4175608" cy="475488"/>
-          </a:xfrm>
-          <a:prstGeom prst="rect">
-            <a:avLst/>
-          </a:prstGeom>
-          <a:noFill/>
-          <a:ln/>
-        </p:spPr>
-        <p:txBody>
-          <a:bodyPr wrap="square" lIns="0" tIns="0" rIns="0" bIns="0" rtlCol="0" anchor="ctr"/>
-          <a:lstStyle/>
-          <a:p>
-            <a:pPr indent="0" marL="0">
-              <a:lnSpc>
-                <a:spcPct val="110000"/>
-              </a:lnSpc>
-              <a:buNone/>
-            </a:pPr>
-            <a:r>
-              <a:rPr lang="en-US" sz="1600" b="1" dirty="0">
-                <a:solidFill>
-                  <a:srgbClr val="16191D"/>
-                </a:solidFill>
-                <a:latin typeface="Arial" pitchFamily="34" charset="0"/>
-                <a:ea typeface="Arial" pitchFamily="34" charset="-122"/>
-                <a:cs typeface="Arial" pitchFamily="34" charset="-120"/>
-              </a:rPr>
-              <a:t>Verify the plan's named test files exist</a:t>
-            </a:r>
-            <a:endParaRPr lang="en-US" sz="1600" dirty="0"/>
-          </a:p>
-        </p:txBody>
-      </p:sp>
-      <p:sp>
-        <p:nvSpPr>
           <p:cNvPr id="18" name="Text 16"/>
           <p:cNvSpPr txBox="1"/>
           <p:nvPr/>
         </p:nvSpPr>
         <p:spPr>
           <a:xfrm>
-            <a:off x="914400" y="4645152"/>
-            <a:ext cx="4724248" cy="914400"/>
-          </a:xfrm>
-          <a:prstGeom prst="rect">
-            <a:avLst/>
-          </a:prstGeom>
-          <a:noFill/>
-          <a:ln/>
-        </p:spPr>
-        <p:txBody>
-          <a:bodyPr wrap="square" lIns="0" tIns="0" rIns="0" bIns="0" rtlCol="0" anchor="t"/>
-          <a:lstStyle/>
-          <a:p>
-            <a:pPr indent="0" marL="0">
-              <a:lnSpc>
-                <a:spcPct val="118000"/>
-              </a:lnSpc>
-              <a:buNone/>
-            </a:pPr>
-            <a:r>
-              <a:rPr lang="en-US" sz="1300" dirty="0">
+            <a:off x="914400" y="5394960"/>
+            <a:ext cx="10362895" cy="713232"/>
+          </a:xfrm>
+          <a:prstGeom prst="rect">
+            <a:avLst/>
+          </a:prstGeom>
+          <a:noFill/>
+          <a:ln/>
+        </p:spPr>
+        <p:txBody>
+          <a:bodyPr wrap="square" lIns="0" tIns="0" rIns="0" bIns="0" rtlCol="0" anchor="ctr"/>
+          <a:lstStyle/>
+          <a:p>
+            <a:pPr indent="0" marL="0">
+              <a:buNone/>
+            </a:pPr>
+            <a:r>
+              <a:rPr lang="en-US" sz="1450" dirty="0">
                 <a:solidFill>
                   <a:srgbClr val="16191D"/>
                 </a:solidFill>
@@ -3812,179 +4057,37 @@
                 <a:ea typeface="Calibri" pitchFamily="34" charset="-122"/>
                 <a:cs typeface="Calibri" pitchFamily="34" charset="-120"/>
               </a:rPr>
-              <a:t>"Gate passed, 635 tests" only proves the tests that exist pass. A plan named two UI test files; they were never created, and an unreachable UI path sailed through every phase gate.</a:t>
-            </a:r>
-            <a:endParaRPr lang="en-US" sz="1300" dirty="0"/>
-          </a:p>
-        </p:txBody>
-      </p:sp>
-      <p:sp>
-        <p:nvSpPr>
-          <p:cNvPr id="19" name="Shape 17"/>
-          <p:cNvSpPr/>
-          <p:nvPr/>
-        </p:nvSpPr>
-        <p:spPr>
-          <a:xfrm>
-            <a:off x="6278728" y="3840480"/>
-            <a:ext cx="5272888" cy="1874520"/>
-          </a:xfrm>
-          <a:prstGeom prst="roundRect">
-            <a:avLst>
-              <a:gd name="adj" fmla="val 2927"/>
-            </a:avLst>
-          </a:prstGeom>
-          <a:solidFill>
-            <a:srgbClr val="F4F5F7"/>
-          </a:solidFill>
-          <a:ln w="12700">
-            <a:solidFill>
-              <a:srgbClr val="DCE0E6"/>
-            </a:solidFill>
-            <a:prstDash val="solid"/>
-          </a:ln>
-        </p:spPr>
-      </p:sp>
-      <p:sp>
-        <p:nvSpPr>
-          <p:cNvPr id="20" name="Shape 18"/>
-          <p:cNvSpPr/>
-          <p:nvPr/>
-        </p:nvSpPr>
-        <p:spPr>
-          <a:xfrm>
-            <a:off x="6553048" y="4096512"/>
-            <a:ext cx="384048" cy="384048"/>
-          </a:xfrm>
-          <a:prstGeom prst="ellipse">
-            <a:avLst/>
-          </a:prstGeom>
-          <a:solidFill>
-            <a:srgbClr val="17795E"/>
-          </a:solidFill>
-          <a:ln/>
-        </p:spPr>
-      </p:sp>
-      <p:sp>
-        <p:nvSpPr>
-          <p:cNvPr id="21" name="Text 19"/>
-          <p:cNvSpPr txBox="1"/>
-          <p:nvPr/>
-        </p:nvSpPr>
-        <p:spPr>
-          <a:xfrm>
-            <a:off x="6553048" y="4096512"/>
-            <a:ext cx="384048" cy="384048"/>
-          </a:xfrm>
-          <a:prstGeom prst="rect">
-            <a:avLst/>
-          </a:prstGeom>
-          <a:noFill/>
-          <a:ln/>
-        </p:spPr>
-        <p:txBody>
-          <a:bodyPr wrap="square" lIns="0" tIns="0" rIns="0" bIns="0" rtlCol="0" anchor="ctr"/>
-          <a:lstStyle/>
-          <a:p>
-            <a:pPr algn="ctr" indent="0" marL="0">
-              <a:buNone/>
-            </a:pPr>
-            <a:r>
-              <a:rPr lang="en-US" sz="1300" b="1" dirty="0">
-                <a:solidFill>
-                  <a:srgbClr val="FFFFFF"/>
-                </a:solidFill>
-                <a:latin typeface="Courier New" pitchFamily="34" charset="0"/>
-                <a:ea typeface="Courier New" pitchFamily="34" charset="-122"/>
-                <a:cs typeface="Courier New" pitchFamily="34" charset="-120"/>
-              </a:rPr>
-              <a:t>4</a:t>
-            </a:r>
-            <a:endParaRPr lang="en-US" sz="1300" dirty="0"/>
-          </a:p>
-        </p:txBody>
-      </p:sp>
-      <p:sp>
-        <p:nvSpPr>
-          <p:cNvPr id="22" name="Text 20"/>
-          <p:cNvSpPr txBox="1"/>
-          <p:nvPr/>
-        </p:nvSpPr>
-        <p:spPr>
-          <a:xfrm>
-            <a:off x="7119976" y="4059936"/>
-            <a:ext cx="4175608" cy="475488"/>
-          </a:xfrm>
-          <a:prstGeom prst="rect">
-            <a:avLst/>
-          </a:prstGeom>
-          <a:noFill/>
-          <a:ln/>
-        </p:spPr>
-        <p:txBody>
-          <a:bodyPr wrap="square" lIns="0" tIns="0" rIns="0" bIns="0" rtlCol="0" anchor="ctr"/>
-          <a:lstStyle/>
-          <a:p>
-            <a:pPr indent="0" marL="0">
-              <a:lnSpc>
-                <a:spcPct val="110000"/>
-              </a:lnSpc>
-              <a:buNone/>
-            </a:pPr>
-            <a:r>
-              <a:rPr lang="en-US" sz="1600" b="1" dirty="0">
-                <a:solidFill>
-                  <a:srgbClr val="16191D"/>
-                </a:solidFill>
-                <a:latin typeface="Arial" pitchFamily="34" charset="0"/>
-                <a:ea typeface="Arial" pitchFamily="34" charset="-122"/>
-                <a:cs typeface="Arial" pitchFamily="34" charset="-120"/>
-              </a:rPr>
-              <a:t>State lives in files, not in context</a:t>
-            </a:r>
-            <a:endParaRPr lang="en-US" sz="1600" dirty="0"/>
-          </a:p>
-        </p:txBody>
-      </p:sp>
-      <p:sp>
-        <p:nvSpPr>
-          <p:cNvPr id="23" name="Text 21"/>
-          <p:cNvSpPr txBox="1"/>
-          <p:nvPr/>
-        </p:nvSpPr>
-        <p:spPr>
-          <a:xfrm>
-            <a:off x="6553048" y="4645152"/>
-            <a:ext cx="4724248" cy="914400"/>
-          </a:xfrm>
-          <a:prstGeom prst="rect">
-            <a:avLst/>
-          </a:prstGeom>
-          <a:noFill/>
-          <a:ln/>
-        </p:spPr>
-        <p:txBody>
-          <a:bodyPr wrap="square" lIns="0" tIns="0" rIns="0" bIns="0" rtlCol="0" anchor="t"/>
-          <a:lstStyle/>
-          <a:p>
-            <a:pPr indent="0" marL="0">
-              <a:lnSpc>
-                <a:spcPct val="118000"/>
-              </a:lnSpc>
-              <a:buNone/>
-            </a:pPr>
-            <a:r>
-              <a:rPr lang="en-US" sz="1300" dirty="0">
-                <a:solidFill>
-                  <a:srgbClr val="16191D"/>
+              <a:t>A model that reasons well and malforms one tool call in fifty </a:t>
+            </a:r>
+            <a:pPr indent="0" marL="0">
+              <a:buNone/>
+            </a:pPr>
+            <a:r>
+              <a:rPr lang="en-US" sz="1450" b="1" dirty="0">
+                <a:solidFill>
+                  <a:srgbClr val="C1690C"/>
                 </a:solidFill>
                 <a:latin typeface="Calibri" pitchFamily="34" charset="0"/>
                 <a:ea typeface="Calibri" pitchFamily="34" charset="-122"/>
                 <a:cs typeface="Calibri" pitchFamily="34" charset="-120"/>
               </a:rPr>
-              <a:t>One AGENTS.md. Architecture and settled decisions in PROJECT_STATE.md, open work in NEXT_STEPS.md, narrative in PROJECT_HISTORY.md. Delegates cannot read an assistant's memory at all.</a:t>
-            </a:r>
-            <a:endParaRPr lang="en-US" sz="1300" dirty="0"/>
+              <a:t>is worse here </a:t>
+            </a:r>
+            <a:pPr indent="0" marL="0">
+              <a:buNone/>
+            </a:pPr>
+            <a:r>
+              <a:rPr lang="en-US" sz="1450" dirty="0">
+                <a:solidFill>
+                  <a:srgbClr val="16191D"/>
+                </a:solidFill>
+                <a:latin typeface="Calibri" pitchFamily="34" charset="0"/>
+                <a:ea typeface="Calibri" pitchFamily="34" charset="-122"/>
+                <a:cs typeface="Calibri" pitchFamily="34" charset="-120"/>
+              </a:rPr>
+              <a:t>than an average model that never breaks the loop.</a:t>
+            </a:r>
+            <a:endParaRPr lang="en-US" sz="1450" dirty="0"/>
           </a:p>
         </p:txBody>
       </p:sp>
@@ -3999,6 +4102,789 @@
 <file path=ppt/slides/slide12.xml><?xml version="1.0" encoding="utf-8"?>
 <p:sld xmlns:a="http://schemas.openxmlformats.org/drawingml/2006/main" xmlns:r="http://schemas.openxmlformats.org/officeDocument/2006/relationships" xmlns:p="http://schemas.openxmlformats.org/presentationml/2006/main">
   <p:cSld name="Slide 12">
+    <p:spTree>
+      <p:nvGrpSpPr>
+        <p:cNvPr id="1" name=""/>
+        <p:cNvGrpSpPr/>
+        <p:nvPr/>
+      </p:nvGrpSpPr>
+      <p:grpSpPr>
+        <a:xfrm>
+          <a:off x="0" y="0"/>
+          <a:ext cx="0" cy="0"/>
+          <a:chOff x="0" y="0"/>
+          <a:chExt cx="0" cy="0"/>
+        </a:xfrm>
+      </p:grpSpPr>
+      <p:sp>
+        <p:nvSpPr>
+          <p:cNvPr id="2" name="Text 0"/>
+          <p:cNvSpPr txBox="1"/>
+          <p:nvPr/>
+        </p:nvSpPr>
+        <p:spPr>
+          <a:xfrm>
+            <a:off x="640080" y="411480"/>
+            <a:ext cx="10911535" cy="731520"/>
+          </a:xfrm>
+          <a:prstGeom prst="rect">
+            <a:avLst/>
+          </a:prstGeom>
+          <a:noFill/>
+          <a:ln/>
+        </p:spPr>
+        <p:txBody>
+          <a:bodyPr wrap="square" lIns="0" tIns="0" rIns="0" bIns="0" rtlCol="0" anchor="ctr"/>
+          <a:lstStyle/>
+          <a:p>
+            <a:pPr algn="l" indent="0" marL="0">
+              <a:buNone/>
+            </a:pPr>
+            <a:r>
+              <a:rPr lang="en-US" sz="3800" b="1" spc="-30" kern="0" dirty="0">
+                <a:solidFill>
+                  <a:srgbClr val="16191D"/>
+                </a:solidFill>
+                <a:latin typeface="Arial" pitchFamily="34" charset="0"/>
+                <a:ea typeface="Arial" pitchFamily="34" charset="-122"/>
+                <a:cs typeface="Arial" pitchFamily="34" charset="-120"/>
+              </a:rPr>
+              <a:t>Decision: the rules that outlive the wiring</a:t>
+            </a:r>
+            <a:endParaRPr lang="en-US" sz="3800" dirty="0"/>
+          </a:p>
+        </p:txBody>
+      </p:sp>
+      <p:sp>
+        <p:nvSpPr>
+          <p:cNvPr id="3" name="Text 1"/>
+          <p:cNvSpPr txBox="1"/>
+          <p:nvPr/>
+        </p:nvSpPr>
+        <p:spPr>
+          <a:xfrm>
+            <a:off x="640080" y="1207008"/>
+            <a:ext cx="10911535" cy="274320"/>
+          </a:xfrm>
+          <a:prstGeom prst="rect">
+            <a:avLst/>
+          </a:prstGeom>
+          <a:noFill/>
+          <a:ln/>
+        </p:spPr>
+        <p:txBody>
+          <a:bodyPr wrap="square" lIns="0" tIns="0" rIns="0" bIns="0" rtlCol="0" anchor="ctr"/>
+          <a:lstStyle/>
+          <a:p>
+            <a:pPr algn="l" indent="0" marL="0">
+              <a:buNone/>
+            </a:pPr>
+            <a:r>
+              <a:rPr lang="en-US" sz="1100" b="1" spc="120" kern="0" dirty="0">
+                <a:solidFill>
+                  <a:srgbClr val="6D4AC4"/>
+                </a:solidFill>
+                <a:latin typeface="Courier New" pitchFamily="34" charset="0"/>
+                <a:ea typeface="Courier New" pitchFamily="34" charset="-122"/>
+                <a:cs typeface="Courier New" pitchFamily="34" charset="-120"/>
+              </a:rPr>
+              <a:t>DECISIONS MADE · 5 OF 5 — THESE APPLY TO ANY UNATTENDED AGENT</a:t>
+            </a:r>
+            <a:endParaRPr lang="en-US" sz="1100" dirty="0"/>
+          </a:p>
+        </p:txBody>
+      </p:sp>
+      <p:sp>
+        <p:nvSpPr>
+          <p:cNvPr id="4" name="Shape 2"/>
+          <p:cNvSpPr/>
+          <p:nvPr/>
+        </p:nvSpPr>
+        <p:spPr>
+          <a:xfrm>
+            <a:off x="640080" y="1737360"/>
+            <a:ext cx="5272888" cy="1874520"/>
+          </a:xfrm>
+          <a:prstGeom prst="roundRect">
+            <a:avLst>
+              <a:gd name="adj" fmla="val 2927"/>
+            </a:avLst>
+          </a:prstGeom>
+          <a:solidFill>
+            <a:srgbClr val="F4F5F7"/>
+          </a:solidFill>
+          <a:ln w="12700">
+            <a:solidFill>
+              <a:srgbClr val="DCE0E6"/>
+            </a:solidFill>
+            <a:prstDash val="solid"/>
+          </a:ln>
+        </p:spPr>
+      </p:sp>
+      <p:sp>
+        <p:nvSpPr>
+          <p:cNvPr id="5" name="Shape 3"/>
+          <p:cNvSpPr/>
+          <p:nvPr/>
+        </p:nvSpPr>
+        <p:spPr>
+          <a:xfrm>
+            <a:off x="914400" y="1993392"/>
+            <a:ext cx="384048" cy="384048"/>
+          </a:xfrm>
+          <a:prstGeom prst="ellipse">
+            <a:avLst/>
+          </a:prstGeom>
+          <a:solidFill>
+            <a:srgbClr val="6D4AC4"/>
+          </a:solidFill>
+          <a:ln/>
+        </p:spPr>
+      </p:sp>
+      <p:sp>
+        <p:nvSpPr>
+          <p:cNvPr id="6" name="Text 4"/>
+          <p:cNvSpPr txBox="1"/>
+          <p:nvPr/>
+        </p:nvSpPr>
+        <p:spPr>
+          <a:xfrm>
+            <a:off x="914400" y="1993392"/>
+            <a:ext cx="384048" cy="384048"/>
+          </a:xfrm>
+          <a:prstGeom prst="rect">
+            <a:avLst/>
+          </a:prstGeom>
+          <a:noFill/>
+          <a:ln/>
+        </p:spPr>
+        <p:txBody>
+          <a:bodyPr wrap="square" lIns="0" tIns="0" rIns="0" bIns="0" rtlCol="0" anchor="ctr"/>
+          <a:lstStyle/>
+          <a:p>
+            <a:pPr algn="ctr" indent="0" marL="0">
+              <a:buNone/>
+            </a:pPr>
+            <a:r>
+              <a:rPr lang="en-US" sz="1300" b="1" dirty="0">
+                <a:solidFill>
+                  <a:srgbClr val="FFFFFF"/>
+                </a:solidFill>
+                <a:latin typeface="Courier New" pitchFamily="34" charset="0"/>
+                <a:ea typeface="Courier New" pitchFamily="34" charset="-122"/>
+                <a:cs typeface="Courier New" pitchFamily="34" charset="-120"/>
+              </a:rPr>
+              <a:t>1</a:t>
+            </a:r>
+            <a:endParaRPr lang="en-US" sz="1300" dirty="0"/>
+          </a:p>
+        </p:txBody>
+      </p:sp>
+      <p:sp>
+        <p:nvSpPr>
+          <p:cNvPr id="7" name="Text 5"/>
+          <p:cNvSpPr txBox="1"/>
+          <p:nvPr/>
+        </p:nvSpPr>
+        <p:spPr>
+          <a:xfrm>
+            <a:off x="1481328" y="1956816"/>
+            <a:ext cx="4175608" cy="475488"/>
+          </a:xfrm>
+          <a:prstGeom prst="rect">
+            <a:avLst/>
+          </a:prstGeom>
+          <a:noFill/>
+          <a:ln/>
+        </p:spPr>
+        <p:txBody>
+          <a:bodyPr wrap="square" lIns="0" tIns="0" rIns="0" bIns="0" rtlCol="0" anchor="ctr"/>
+          <a:lstStyle/>
+          <a:p>
+            <a:pPr indent="0" marL="0">
+              <a:lnSpc>
+                <a:spcPct val="110000"/>
+              </a:lnSpc>
+              <a:buNone/>
+            </a:pPr>
+            <a:r>
+              <a:rPr lang="en-US" sz="1600" b="1" dirty="0">
+                <a:solidFill>
+                  <a:srgbClr val="16191D"/>
+                </a:solidFill>
+                <a:latin typeface="Arial" pitchFamily="34" charset="0"/>
+                <a:ea typeface="Arial" pitchFamily="34" charset="-122"/>
+                <a:cs typeface="Arial" pitchFamily="34" charset="-120"/>
+              </a:rPr>
+              <a:t>The deliverable is a file, never stdout</a:t>
+            </a:r>
+            <a:endParaRPr lang="en-US" sz="1600" dirty="0"/>
+          </a:p>
+        </p:txBody>
+      </p:sp>
+      <p:sp>
+        <p:nvSpPr>
+          <p:cNvPr id="8" name="Text 6"/>
+          <p:cNvSpPr txBox="1"/>
+          <p:nvPr/>
+        </p:nvSpPr>
+        <p:spPr>
+          <a:xfrm>
+            <a:off x="914400" y="2542032"/>
+            <a:ext cx="4724248" cy="914400"/>
+          </a:xfrm>
+          <a:prstGeom prst="rect">
+            <a:avLst/>
+          </a:prstGeom>
+          <a:noFill/>
+          <a:ln/>
+        </p:spPr>
+        <p:txBody>
+          <a:bodyPr wrap="square" lIns="0" tIns="0" rIns="0" bIns="0" rtlCol="0" anchor="t"/>
+          <a:lstStyle/>
+          <a:p>
+            <a:pPr indent="0" marL="0">
+              <a:lnSpc>
+                <a:spcPct val="118000"/>
+              </a:lnSpc>
+              <a:buNone/>
+            </a:pPr>
+            <a:r>
+              <a:rPr lang="en-US" sz="1300" dirty="0">
+                <a:solidFill>
+                  <a:srgbClr val="16191D"/>
+                </a:solidFill>
+                <a:latin typeface="Calibri" pitchFamily="34" charset="0"/>
+                <a:ea typeface="Calibri" pitchFamily="34" charset="-122"/>
+                <a:cs typeface="Calibri" pitchFamily="34" charset="-120"/>
+              </a:rPr>
+              <a:t>stdout is lost outright when the transport drops and truncated when a run is killed. A brief that says "print your review" has a total-loss failure mode — verified on an hour of real work.</a:t>
+            </a:r>
+            <a:endParaRPr lang="en-US" sz="1300" dirty="0"/>
+          </a:p>
+        </p:txBody>
+      </p:sp>
+      <p:sp>
+        <p:nvSpPr>
+          <p:cNvPr id="9" name="Shape 7"/>
+          <p:cNvSpPr/>
+          <p:nvPr/>
+        </p:nvSpPr>
+        <p:spPr>
+          <a:xfrm>
+            <a:off x="6278728" y="1737360"/>
+            <a:ext cx="5272888" cy="1874520"/>
+          </a:xfrm>
+          <a:prstGeom prst="roundRect">
+            <a:avLst>
+              <a:gd name="adj" fmla="val 2927"/>
+            </a:avLst>
+          </a:prstGeom>
+          <a:solidFill>
+            <a:srgbClr val="F4F5F7"/>
+          </a:solidFill>
+          <a:ln w="12700">
+            <a:solidFill>
+              <a:srgbClr val="DCE0E6"/>
+            </a:solidFill>
+            <a:prstDash val="solid"/>
+          </a:ln>
+        </p:spPr>
+      </p:sp>
+      <p:sp>
+        <p:nvSpPr>
+          <p:cNvPr id="10" name="Shape 8"/>
+          <p:cNvSpPr/>
+          <p:nvPr/>
+        </p:nvSpPr>
+        <p:spPr>
+          <a:xfrm>
+            <a:off x="6553048" y="1993392"/>
+            <a:ext cx="384048" cy="384048"/>
+          </a:xfrm>
+          <a:prstGeom prst="ellipse">
+            <a:avLst/>
+          </a:prstGeom>
+          <a:solidFill>
+            <a:srgbClr val="17795E"/>
+          </a:solidFill>
+          <a:ln/>
+        </p:spPr>
+      </p:sp>
+      <p:sp>
+        <p:nvSpPr>
+          <p:cNvPr id="11" name="Text 9"/>
+          <p:cNvSpPr txBox="1"/>
+          <p:nvPr/>
+        </p:nvSpPr>
+        <p:spPr>
+          <a:xfrm>
+            <a:off x="6553048" y="1993392"/>
+            <a:ext cx="384048" cy="384048"/>
+          </a:xfrm>
+          <a:prstGeom prst="rect">
+            <a:avLst/>
+          </a:prstGeom>
+          <a:noFill/>
+          <a:ln/>
+        </p:spPr>
+        <p:txBody>
+          <a:bodyPr wrap="square" lIns="0" tIns="0" rIns="0" bIns="0" rtlCol="0" anchor="ctr"/>
+          <a:lstStyle/>
+          <a:p>
+            <a:pPr algn="ctr" indent="0" marL="0">
+              <a:buNone/>
+            </a:pPr>
+            <a:r>
+              <a:rPr lang="en-US" sz="1300" b="1" dirty="0">
+                <a:solidFill>
+                  <a:srgbClr val="FFFFFF"/>
+                </a:solidFill>
+                <a:latin typeface="Courier New" pitchFamily="34" charset="0"/>
+                <a:ea typeface="Courier New" pitchFamily="34" charset="-122"/>
+                <a:cs typeface="Courier New" pitchFamily="34" charset="-120"/>
+              </a:rPr>
+              <a:t>2</a:t>
+            </a:r>
+            <a:endParaRPr lang="en-US" sz="1300" dirty="0"/>
+          </a:p>
+        </p:txBody>
+      </p:sp>
+      <p:sp>
+        <p:nvSpPr>
+          <p:cNvPr id="12" name="Text 10"/>
+          <p:cNvSpPr txBox="1"/>
+          <p:nvPr/>
+        </p:nvSpPr>
+        <p:spPr>
+          <a:xfrm>
+            <a:off x="7119976" y="1956816"/>
+            <a:ext cx="4175608" cy="475488"/>
+          </a:xfrm>
+          <a:prstGeom prst="rect">
+            <a:avLst/>
+          </a:prstGeom>
+          <a:noFill/>
+          <a:ln/>
+        </p:spPr>
+        <p:txBody>
+          <a:bodyPr wrap="square" lIns="0" tIns="0" rIns="0" bIns="0" rtlCol="0" anchor="ctr"/>
+          <a:lstStyle/>
+          <a:p>
+            <a:pPr indent="0" marL="0">
+              <a:lnSpc>
+                <a:spcPct val="110000"/>
+              </a:lnSpc>
+              <a:buNone/>
+            </a:pPr>
+            <a:r>
+              <a:rPr lang="en-US" sz="1600" b="1" dirty="0">
+                <a:solidFill>
+                  <a:srgbClr val="16191D"/>
+                </a:solidFill>
+                <a:latin typeface="Arial" pitchFamily="34" charset="0"/>
+                <a:ea typeface="Arial" pitchFamily="34" charset="-122"/>
+                <a:cs typeface="Arial" pitchFamily="34" charset="-120"/>
+              </a:rPr>
+              <a:t>Match plan detail to model strength</a:t>
+            </a:r>
+            <a:endParaRPr lang="en-US" sz="1600" dirty="0"/>
+          </a:p>
+        </p:txBody>
+      </p:sp>
+      <p:sp>
+        <p:nvSpPr>
+          <p:cNvPr id="13" name="Text 11"/>
+          <p:cNvSpPr txBox="1"/>
+          <p:nvPr/>
+        </p:nvSpPr>
+        <p:spPr>
+          <a:xfrm>
+            <a:off x="6553048" y="2542032"/>
+            <a:ext cx="4724248" cy="914400"/>
+          </a:xfrm>
+          <a:prstGeom prst="rect">
+            <a:avLst/>
+          </a:prstGeom>
+          <a:noFill/>
+          <a:ln/>
+        </p:spPr>
+        <p:txBody>
+          <a:bodyPr wrap="square" lIns="0" tIns="0" rIns="0" bIns="0" rtlCol="0" anchor="t"/>
+          <a:lstStyle/>
+          <a:p>
+            <a:pPr indent="0" marL="0">
+              <a:lnSpc>
+                <a:spcPct val="118000"/>
+              </a:lnSpc>
+              <a:buNone/>
+            </a:pPr>
+            <a:r>
+              <a:rPr lang="en-US" sz="1300" dirty="0">
+                <a:solidFill>
+                  <a:srgbClr val="16191D"/>
+                </a:solidFill>
+                <a:latin typeface="Calibri" pitchFamily="34" charset="0"/>
+                <a:ea typeface="Calibri" pitchFamily="34" charset="-122"/>
+                <a:cs typeface="Calibri" pitchFamily="34" charset="-120"/>
+              </a:rPr>
+              <a:t>Flash tier gets exact files, exact before/after code, an explicit do-not-touch list, and zero open questions. Frontier tier gets intent, invariants and phase gates.</a:t>
+            </a:r>
+            <a:endParaRPr lang="en-US" sz="1300" dirty="0"/>
+          </a:p>
+        </p:txBody>
+      </p:sp>
+      <p:sp>
+        <p:nvSpPr>
+          <p:cNvPr id="14" name="Shape 12"/>
+          <p:cNvSpPr/>
+          <p:nvPr/>
+        </p:nvSpPr>
+        <p:spPr>
+          <a:xfrm>
+            <a:off x="640080" y="3840480"/>
+            <a:ext cx="5272888" cy="1874520"/>
+          </a:xfrm>
+          <a:prstGeom prst="roundRect">
+            <a:avLst>
+              <a:gd name="adj" fmla="val 2927"/>
+            </a:avLst>
+          </a:prstGeom>
+          <a:solidFill>
+            <a:srgbClr val="F4F5F7"/>
+          </a:solidFill>
+          <a:ln w="12700">
+            <a:solidFill>
+              <a:srgbClr val="DCE0E6"/>
+            </a:solidFill>
+            <a:prstDash val="solid"/>
+          </a:ln>
+        </p:spPr>
+      </p:sp>
+      <p:sp>
+        <p:nvSpPr>
+          <p:cNvPr id="15" name="Shape 13"/>
+          <p:cNvSpPr/>
+          <p:nvPr/>
+        </p:nvSpPr>
+        <p:spPr>
+          <a:xfrm>
+            <a:off x="914400" y="4096512"/>
+            <a:ext cx="384048" cy="384048"/>
+          </a:xfrm>
+          <a:prstGeom prst="ellipse">
+            <a:avLst/>
+          </a:prstGeom>
+          <a:solidFill>
+            <a:srgbClr val="6D4AC4"/>
+          </a:solidFill>
+          <a:ln/>
+        </p:spPr>
+      </p:sp>
+      <p:sp>
+        <p:nvSpPr>
+          <p:cNvPr id="16" name="Text 14"/>
+          <p:cNvSpPr txBox="1"/>
+          <p:nvPr/>
+        </p:nvSpPr>
+        <p:spPr>
+          <a:xfrm>
+            <a:off x="914400" y="4096512"/>
+            <a:ext cx="384048" cy="384048"/>
+          </a:xfrm>
+          <a:prstGeom prst="rect">
+            <a:avLst/>
+          </a:prstGeom>
+          <a:noFill/>
+          <a:ln/>
+        </p:spPr>
+        <p:txBody>
+          <a:bodyPr wrap="square" lIns="0" tIns="0" rIns="0" bIns="0" rtlCol="0" anchor="ctr"/>
+          <a:lstStyle/>
+          <a:p>
+            <a:pPr algn="ctr" indent="0" marL="0">
+              <a:buNone/>
+            </a:pPr>
+            <a:r>
+              <a:rPr lang="en-US" sz="1300" b="1" dirty="0">
+                <a:solidFill>
+                  <a:srgbClr val="FFFFFF"/>
+                </a:solidFill>
+                <a:latin typeface="Courier New" pitchFamily="34" charset="0"/>
+                <a:ea typeface="Courier New" pitchFamily="34" charset="-122"/>
+                <a:cs typeface="Courier New" pitchFamily="34" charset="-120"/>
+              </a:rPr>
+              <a:t>3</a:t>
+            </a:r>
+            <a:endParaRPr lang="en-US" sz="1300" dirty="0"/>
+          </a:p>
+        </p:txBody>
+      </p:sp>
+      <p:sp>
+        <p:nvSpPr>
+          <p:cNvPr id="17" name="Text 15"/>
+          <p:cNvSpPr txBox="1"/>
+          <p:nvPr/>
+        </p:nvSpPr>
+        <p:spPr>
+          <a:xfrm>
+            <a:off x="1481328" y="4059936"/>
+            <a:ext cx="4175608" cy="475488"/>
+          </a:xfrm>
+          <a:prstGeom prst="rect">
+            <a:avLst/>
+          </a:prstGeom>
+          <a:noFill/>
+          <a:ln/>
+        </p:spPr>
+        <p:txBody>
+          <a:bodyPr wrap="square" lIns="0" tIns="0" rIns="0" bIns="0" rtlCol="0" anchor="ctr"/>
+          <a:lstStyle/>
+          <a:p>
+            <a:pPr indent="0" marL="0">
+              <a:lnSpc>
+                <a:spcPct val="110000"/>
+              </a:lnSpc>
+              <a:buNone/>
+            </a:pPr>
+            <a:r>
+              <a:rPr lang="en-US" sz="1600" b="1" dirty="0">
+                <a:solidFill>
+                  <a:srgbClr val="16191D"/>
+                </a:solidFill>
+                <a:latin typeface="Arial" pitchFamily="34" charset="0"/>
+                <a:ea typeface="Arial" pitchFamily="34" charset="-122"/>
+                <a:cs typeface="Arial" pitchFamily="34" charset="-120"/>
+              </a:rPr>
+              <a:t>Verify the plan's named test files exist</a:t>
+            </a:r>
+            <a:endParaRPr lang="en-US" sz="1600" dirty="0"/>
+          </a:p>
+        </p:txBody>
+      </p:sp>
+      <p:sp>
+        <p:nvSpPr>
+          <p:cNvPr id="18" name="Text 16"/>
+          <p:cNvSpPr txBox="1"/>
+          <p:nvPr/>
+        </p:nvSpPr>
+        <p:spPr>
+          <a:xfrm>
+            <a:off x="914400" y="4645152"/>
+            <a:ext cx="4724248" cy="914400"/>
+          </a:xfrm>
+          <a:prstGeom prst="rect">
+            <a:avLst/>
+          </a:prstGeom>
+          <a:noFill/>
+          <a:ln/>
+        </p:spPr>
+        <p:txBody>
+          <a:bodyPr wrap="square" lIns="0" tIns="0" rIns="0" bIns="0" rtlCol="0" anchor="t"/>
+          <a:lstStyle/>
+          <a:p>
+            <a:pPr indent="0" marL="0">
+              <a:lnSpc>
+                <a:spcPct val="118000"/>
+              </a:lnSpc>
+              <a:buNone/>
+            </a:pPr>
+            <a:r>
+              <a:rPr lang="en-US" sz="1300" dirty="0">
+                <a:solidFill>
+                  <a:srgbClr val="16191D"/>
+                </a:solidFill>
+                <a:latin typeface="Calibri" pitchFamily="34" charset="0"/>
+                <a:ea typeface="Calibri" pitchFamily="34" charset="-122"/>
+                <a:cs typeface="Calibri" pitchFamily="34" charset="-120"/>
+              </a:rPr>
+              <a:t>"Gate passed, 635 tests" only proves the tests that exist pass. A plan named two UI test files; they were never created, and an unreachable UI path sailed through every phase gate.</a:t>
+            </a:r>
+            <a:endParaRPr lang="en-US" sz="1300" dirty="0"/>
+          </a:p>
+        </p:txBody>
+      </p:sp>
+      <p:sp>
+        <p:nvSpPr>
+          <p:cNvPr id="19" name="Shape 17"/>
+          <p:cNvSpPr/>
+          <p:nvPr/>
+        </p:nvSpPr>
+        <p:spPr>
+          <a:xfrm>
+            <a:off x="6278728" y="3840480"/>
+            <a:ext cx="5272888" cy="1874520"/>
+          </a:xfrm>
+          <a:prstGeom prst="roundRect">
+            <a:avLst>
+              <a:gd name="adj" fmla="val 2927"/>
+            </a:avLst>
+          </a:prstGeom>
+          <a:solidFill>
+            <a:srgbClr val="F4F5F7"/>
+          </a:solidFill>
+          <a:ln w="12700">
+            <a:solidFill>
+              <a:srgbClr val="DCE0E6"/>
+            </a:solidFill>
+            <a:prstDash val="solid"/>
+          </a:ln>
+        </p:spPr>
+      </p:sp>
+      <p:sp>
+        <p:nvSpPr>
+          <p:cNvPr id="20" name="Shape 18"/>
+          <p:cNvSpPr/>
+          <p:nvPr/>
+        </p:nvSpPr>
+        <p:spPr>
+          <a:xfrm>
+            <a:off x="6553048" y="4096512"/>
+            <a:ext cx="384048" cy="384048"/>
+          </a:xfrm>
+          <a:prstGeom prst="ellipse">
+            <a:avLst/>
+          </a:prstGeom>
+          <a:solidFill>
+            <a:srgbClr val="17795E"/>
+          </a:solidFill>
+          <a:ln/>
+        </p:spPr>
+      </p:sp>
+      <p:sp>
+        <p:nvSpPr>
+          <p:cNvPr id="21" name="Text 19"/>
+          <p:cNvSpPr txBox="1"/>
+          <p:nvPr/>
+        </p:nvSpPr>
+        <p:spPr>
+          <a:xfrm>
+            <a:off x="6553048" y="4096512"/>
+            <a:ext cx="384048" cy="384048"/>
+          </a:xfrm>
+          <a:prstGeom prst="rect">
+            <a:avLst/>
+          </a:prstGeom>
+          <a:noFill/>
+          <a:ln/>
+        </p:spPr>
+        <p:txBody>
+          <a:bodyPr wrap="square" lIns="0" tIns="0" rIns="0" bIns="0" rtlCol="0" anchor="ctr"/>
+          <a:lstStyle/>
+          <a:p>
+            <a:pPr algn="ctr" indent="0" marL="0">
+              <a:buNone/>
+            </a:pPr>
+            <a:r>
+              <a:rPr lang="en-US" sz="1300" b="1" dirty="0">
+                <a:solidFill>
+                  <a:srgbClr val="FFFFFF"/>
+                </a:solidFill>
+                <a:latin typeface="Courier New" pitchFamily="34" charset="0"/>
+                <a:ea typeface="Courier New" pitchFamily="34" charset="-122"/>
+                <a:cs typeface="Courier New" pitchFamily="34" charset="-120"/>
+              </a:rPr>
+              <a:t>4</a:t>
+            </a:r>
+            <a:endParaRPr lang="en-US" sz="1300" dirty="0"/>
+          </a:p>
+        </p:txBody>
+      </p:sp>
+      <p:sp>
+        <p:nvSpPr>
+          <p:cNvPr id="22" name="Text 20"/>
+          <p:cNvSpPr txBox="1"/>
+          <p:nvPr/>
+        </p:nvSpPr>
+        <p:spPr>
+          <a:xfrm>
+            <a:off x="7119976" y="4059936"/>
+            <a:ext cx="4175608" cy="475488"/>
+          </a:xfrm>
+          <a:prstGeom prst="rect">
+            <a:avLst/>
+          </a:prstGeom>
+          <a:noFill/>
+          <a:ln/>
+        </p:spPr>
+        <p:txBody>
+          <a:bodyPr wrap="square" lIns="0" tIns="0" rIns="0" bIns="0" rtlCol="0" anchor="ctr"/>
+          <a:lstStyle/>
+          <a:p>
+            <a:pPr indent="0" marL="0">
+              <a:lnSpc>
+                <a:spcPct val="110000"/>
+              </a:lnSpc>
+              <a:buNone/>
+            </a:pPr>
+            <a:r>
+              <a:rPr lang="en-US" sz="1600" b="1" dirty="0">
+                <a:solidFill>
+                  <a:srgbClr val="16191D"/>
+                </a:solidFill>
+                <a:latin typeface="Arial" pitchFamily="34" charset="0"/>
+                <a:ea typeface="Arial" pitchFamily="34" charset="-122"/>
+                <a:cs typeface="Arial" pitchFamily="34" charset="-120"/>
+              </a:rPr>
+              <a:t>State lives in files, not in context</a:t>
+            </a:r>
+            <a:endParaRPr lang="en-US" sz="1600" dirty="0"/>
+          </a:p>
+        </p:txBody>
+      </p:sp>
+      <p:sp>
+        <p:nvSpPr>
+          <p:cNvPr id="23" name="Text 21"/>
+          <p:cNvSpPr txBox="1"/>
+          <p:nvPr/>
+        </p:nvSpPr>
+        <p:spPr>
+          <a:xfrm>
+            <a:off x="6553048" y="4645152"/>
+            <a:ext cx="4724248" cy="914400"/>
+          </a:xfrm>
+          <a:prstGeom prst="rect">
+            <a:avLst/>
+          </a:prstGeom>
+          <a:noFill/>
+          <a:ln/>
+        </p:spPr>
+        <p:txBody>
+          <a:bodyPr wrap="square" lIns="0" tIns="0" rIns="0" bIns="0" rtlCol="0" anchor="t"/>
+          <a:lstStyle/>
+          <a:p>
+            <a:pPr indent="0" marL="0">
+              <a:lnSpc>
+                <a:spcPct val="118000"/>
+              </a:lnSpc>
+              <a:buNone/>
+            </a:pPr>
+            <a:r>
+              <a:rPr lang="en-US" sz="1300" dirty="0">
+                <a:solidFill>
+                  <a:srgbClr val="16191D"/>
+                </a:solidFill>
+                <a:latin typeface="Calibri" pitchFamily="34" charset="0"/>
+                <a:ea typeface="Calibri" pitchFamily="34" charset="-122"/>
+                <a:cs typeface="Calibri" pitchFamily="34" charset="-120"/>
+              </a:rPr>
+              <a:t>One AGENTS.md. Architecture and settled decisions in PROJECT_STATE.md, open work in NEXT_STEPS.md, narrative in PROJECT_HISTORY.md. Delegates cannot read an assistant's memory at all.</a:t>
+            </a:r>
+            <a:endParaRPr lang="en-US" sz="1300" dirty="0"/>
+          </a:p>
+        </p:txBody>
+      </p:sp>
+    </p:spTree>
+  </p:cSld>
+  <p:clrMapOvr>
+    <a:masterClrMapping/>
+  </p:clrMapOvr>
+</p:sld>
+</file>
+
+<file path=ppt/slides/slide13.xml><?xml version="1.0" encoding="utf-8"?>
+<p:sld xmlns:a="http://schemas.openxmlformats.org/drawingml/2006/main" xmlns:r="http://schemas.openxmlformats.org/officeDocument/2006/relationships" xmlns:p="http://schemas.openxmlformats.org/presentationml/2006/main">
+  <p:cSld name="Slide 13">
     <p:bg>
       <p:bgPr>
         <a:solidFill>
@@ -9936,7 +10822,7 @@
                 <a:ea typeface="Courier New" pitchFamily="34" charset="-122"/>
                 <a:cs typeface="Courier New" pitchFamily="34" charset="-120"/>
               </a:rPr>
-              <a:t>DECISIONS MADE · 1 OF 4</a:t>
+              <a:t>DECISIONS MADE · 1 OF 5</a:t>
             </a:r>
             <a:endParaRPr lang="en-US" sz="1100" dirty="0"/>
           </a:p>
@@ -10506,7 +11392,7 @@
                 <a:ea typeface="Courier New" pitchFamily="34" charset="-122"/>
                 <a:cs typeface="Courier New" pitchFamily="34" charset="-120"/>
               </a:rPr>
-              <a:t>DECISIONS MADE · 2 OF 4</a:t>
+              <a:t>DECISIONS MADE · 2 OF 5</a:t>
             </a:r>
             <a:endParaRPr lang="en-US" sz="1100" dirty="0"/>
           </a:p>

</xml_diff>